<commit_message>
Tautan sumber pada slide matriks literatur dan log pelaksanaan eksperimen
- Slide matriks literatur disamakan dengan 8 paper inti pada dokumen P2
  (sebelumnya tercampur entri dari Tinjauan Pustaka), ditambah kolom Sumber
  berisi tautan DOI/arXiv per paper serta tautan ke dokumen matriks,
  tinjauan pustaka, dan research gap di repositori.
- Slide P1 melengkapi manfaat dengan tiga kontribusi ilmiah sesuai Deskripsi
  Penelitian bagian 6.
- Tambah hasil_eksperimen/log_pelaksanaan_eksperimen.md sebagai luaran
  Pertemuan 5 yang sebelumnya belum ada: identitas eksekusi, tahapan,
  checksum luaran, dan verifikasi replikasi (seluruh luaran identik saat
  pipeline dijalankan ulang dengan seed 42).

Co-Authored-By: Claude Opus 5 <noreply@anthropic.com>
</commit_message>
<xml_diff>
--- a/05_presentasi_progres/PRE02_Presentasi_Progres_Pertemuan1-5.pptx
+++ b/05_presentasi_progres/PRE02_Presentasi_Progres_Pertemuan1-5.pptx
@@ -13526,7 +13526,7 @@
                         </a:defRPr>
                       </a:pPr>
                       <a:r>
-                        <a:t>5 berkas hasil (metrik, prediksi, 3 grafik) + ringkasan temuan otomatis</a:t>
+                        <a:t>4 tabel + 3 grafik + ringkasan temuan otomatis; log pelaksanaan dan verifikasi replikasi</a:t>
                       </a:r>
                     </a:p>
                   </a:txBody>
@@ -14586,7 +14586,7 @@
               </a:defRPr>
             </a:pPr>
             <a:r>
-              <a:t>MANFAAT</a:t>
+              <a:t>MANFAAT DAN KONTRIBUSI ILMIAH</a:t>
             </a:r>
           </a:p>
         </p:txBody>
@@ -14642,6 +14642,54 @@
             </a:pPr>
             <a:r>
               <a:t>•  Akademis: kerangka predictive monitoring probabilistik yang diuji kalibrasinya, bukan sekadar akurasi.</a:t>
+            </a:r>
+          </a:p>
+          <a:p>
+            <a:pPr algn="l">
+              <a:lnSpc>
+                <a:spcPct val="125000"/>
+              </a:lnSpc>
+              <a:defRPr sz="1050" b="0">
+                <a:solidFill>
+                  <a:srgbClr val="233324"/>
+                </a:solidFill>
+                <a:latin typeface="Calibri"/>
+              </a:defRPr>
+            </a:pPr>
+            <a:r>
+              <a:t>•  Kontribusi 1: early warning system dengan probabilitas keterlambatan yang kuantitatif dan terkalibrasi.</a:t>
+            </a:r>
+          </a:p>
+          <a:p>
+            <a:pPr algn="l">
+              <a:lnSpc>
+                <a:spcPct val="125000"/>
+              </a:lnSpc>
+              <a:defRPr sz="1050" b="0">
+                <a:solidFill>
+                  <a:srgbClr val="233324"/>
+                </a:solidFill>
+                <a:latin typeface="Calibri"/>
+              </a:defRPr>
+            </a:pPr>
+            <a:r>
+              <a:t>•  Kontribusi 2: informasi probabilitas sebagai dasar pengambilan keputusan berbasis risiko.</a:t>
+            </a:r>
+          </a:p>
+          <a:p>
+            <a:pPr algn="l">
+              <a:lnSpc>
+                <a:spcPct val="125000"/>
+              </a:lnSpc>
+              <a:defRPr sz="1050" b="0">
+                <a:solidFill>
+                  <a:srgbClr val="233324"/>
+                </a:solidFill>
+                <a:latin typeface="Calibri"/>
+              </a:defRPr>
+            </a:pPr>
+            <a:r>
+              <a:t>•  Kontribusi 3: kerangka monitoring prediktif yang dapat diintegrasikan ke sistem manajemen proyek.</a:t>
             </a:r>
           </a:p>
         </p:txBody>
@@ -15822,7 +15870,7 @@
               </a:defRPr>
             </a:pPr>
             <a:r>
-              <a:t>Matriks Literatur: Paper Inti dan Posisinya</a:t>
+              <a:t>Matriks Literatur: Delapan Paper Inti dan Posisinya</a:t>
             </a:r>
           </a:p>
         </p:txBody>
@@ -15953,7 +16001,7 @@
           <p:nvPr/>
         </p:nvGraphicFramePr>
         <p:xfrm>
-          <a:off x="731520" y="1874519"/>
+          <a:off x="731520" y="1828800"/>
           <a:ext cx="10744200" cy="3657600"/>
         </p:xfrm>
         <a:graphic>
@@ -15963,10 +16011,11 @@
                 <a:tableStyleId>{5C22544A-7EE6-4342-B048-85BDC9FD1C3A}</a:tableStyleId>
               </a:tblPr>
               <a:tblGrid>
-                <a:gridCol w="2788920"/>
-                <a:gridCol w="2468880"/>
-                <a:gridCol w="2468880"/>
-                <a:gridCol w="3017520"/>
+                <a:gridCol w="2514600"/>
+                <a:gridCol w="2331720"/>
+                <a:gridCol w="2240280"/>
+                <a:gridCol w="2606040"/>
+                <a:gridCol w="1051560"/>
               </a:tblGrid>
               <a:tr h="438912">
                 <a:tc>
@@ -16065,6 +16114,30 @@
                     </a:solidFill>
                   </a:tcPr>
                 </a:tc>
+                <a:tc>
+                  <a:txBody>
+                    <a:bodyPr/>
+                    <a:lstStyle/>
+                    <a:p>
+                      <a:pPr algn="ctr">
+                        <a:defRPr sz="950" b="1">
+                          <a:solidFill>
+                            <a:srgbClr val="FFFFFF"/>
+                          </a:solidFill>
+                          <a:latin typeface="Calibri"/>
+                        </a:defRPr>
+                      </a:pPr>
+                      <a:r>
+                        <a:t>Sumber</a:t>
+                      </a:r>
+                    </a:p>
+                  </a:txBody>
+                  <a:tcPr marL="73152" marR="73152" marT="18288" marB="18288" anchor="ctr">
+                    <a:solidFill>
+                      <a:srgbClr val="1E4220"/>
+                    </a:solidFill>
+                  </a:tcPr>
+                </a:tc>
               </a:tr>
               <a:tr h="402336">
                 <a:tc>
@@ -16163,6 +16236,36 @@
                     </a:solidFill>
                   </a:tcPr>
                 </a:tc>
+                <a:tc>
+                  <a:txBody>
+                    <a:bodyPr/>
+                    <a:lstStyle/>
+                    <a:p>
+                      <a:pPr algn="ctr">
+                        <a:defRPr sz="950" b="0">
+                          <a:solidFill>
+                            <a:srgbClr val="233324"/>
+                          </a:solidFill>
+                          <a:latin typeface="Calibri"/>
+                        </a:defRPr>
+                      </a:pPr>
+                      <a:r>
+                        <a:rPr u="sng">
+                          <a:solidFill>
+                            <a:srgbClr val="2C5F2D"/>
+                          </a:solidFill>
+                          <a:hlinkClick r:id="rId2"/>
+                        </a:rPr>
+                        <a:t>DOI ↗</a:t>
+                      </a:r>
+                    </a:p>
+                  </a:txBody>
+                  <a:tcPr marL="73152" marR="73152" marT="18288" marB="18288" anchor="ctr">
+                    <a:solidFill>
+                      <a:srgbClr val="FFFFFF"/>
+                    </a:solidFill>
+                  </a:tcPr>
+                </a:tc>
               </a:tr>
               <a:tr h="402336">
                 <a:tc>
@@ -16203,7 +16306,7 @@
                         </a:defRPr>
                       </a:pPr>
                       <a:r>
-                        <a:t>Machine learning vs EVM</a:t>
+                        <a:t>Decision tree, RF, boosting, SVM</a:t>
                       </a:r>
                     </a:p>
                   </a:txBody>
@@ -16261,6 +16364,36 @@
                     </a:solidFill>
                   </a:tcPr>
                 </a:tc>
+                <a:tc>
+                  <a:txBody>
+                    <a:bodyPr/>
+                    <a:lstStyle/>
+                    <a:p>
+                      <a:pPr algn="ctr">
+                        <a:defRPr sz="950" b="0">
+                          <a:solidFill>
+                            <a:srgbClr val="233324"/>
+                          </a:solidFill>
+                          <a:latin typeface="Calibri"/>
+                        </a:defRPr>
+                      </a:pPr>
+                      <a:r>
+                        <a:rPr u="sng">
+                          <a:solidFill>
+                            <a:srgbClr val="2C5F2D"/>
+                          </a:solidFill>
+                          <a:hlinkClick r:id="rId3"/>
+                        </a:rPr>
+                        <a:t>DOI ↗</a:t>
+                      </a:r>
+                    </a:p>
+                  </a:txBody>
+                  <a:tcPr marL="73152" marR="73152" marT="18288" marB="18288" anchor="ctr">
+                    <a:solidFill>
+                      <a:srgbClr val="F4F7F1"/>
+                    </a:solidFill>
+                  </a:tcPr>
+                </a:tc>
               </a:tr>
               <a:tr h="402336">
                 <a:tc>
@@ -16277,7 +16410,7 @@
                         </a:defRPr>
                       </a:pPr>
                       <a:r>
-                        <a:t>Gondia et al. (2020)</a:t>
+                        <a:t>Choetkiertikul et al. (2017)</a:t>
                       </a:r>
                     </a:p>
                   </a:txBody>
@@ -16301,7 +16434,7 @@
                         </a:defRPr>
                       </a:pPr>
                       <a:r>
-                        <a:t>Decision tree, Naive Bayes</a:t>
+                        <a:t>Random Forest + dependency link</a:t>
                       </a:r>
                     </a:p>
                   </a:txBody>
@@ -16325,7 +16458,7 @@
                         </a:defRPr>
                       </a:pPr>
                       <a:r>
-                        <a:t>Kelas risiko keterlambatan</a:t>
+                        <a:t>Klasifikasi delay issue software</a:t>
                       </a:r>
                     </a:p>
                   </a:txBody>
@@ -16349,7 +16482,37 @@
                         </a:defRPr>
                       </a:pPr>
                       <a:r>
-                        <a:t>Luaran kelas diskret, kalibrasi tidak diuji</a:t>
+                        <a:t>Luaran biner, kalibrasi tidak diuji</a:t>
+                      </a:r>
+                    </a:p>
+                  </a:txBody>
+                  <a:tcPr marL="73152" marR="73152" marT="18288" marB="18288" anchor="ctr">
+                    <a:solidFill>
+                      <a:srgbClr val="FFFFFF"/>
+                    </a:solidFill>
+                  </a:tcPr>
+                </a:tc>
+                <a:tc>
+                  <a:txBody>
+                    <a:bodyPr/>
+                    <a:lstStyle/>
+                    <a:p>
+                      <a:pPr algn="ctr">
+                        <a:defRPr sz="950" b="0">
+                          <a:solidFill>
+                            <a:srgbClr val="233324"/>
+                          </a:solidFill>
+                          <a:latin typeface="Calibri"/>
+                        </a:defRPr>
+                      </a:pPr>
+                      <a:r>
+                        <a:rPr u="sng">
+                          <a:solidFill>
+                            <a:srgbClr val="2C5F2D"/>
+                          </a:solidFill>
+                          <a:hlinkClick r:id="rId4"/>
+                        </a:rPr>
+                        <a:t>DOI ↗</a:t>
                       </a:r>
                     </a:p>
                   </a:txBody>
@@ -16375,7 +16538,7 @@
                         </a:defRPr>
                       </a:pPr>
                       <a:r>
-                        <a:t>Browning &amp; Yassine (2010)</a:t>
+                        <a:t>Gondia et al. (2020)</a:t>
                       </a:r>
                     </a:p>
                   </a:txBody>
@@ -16399,7 +16562,7 @@
                         </a:defRPr>
                       </a:pPr>
                       <a:r>
-                        <a:t>Penjadwalan multi-proyek</a:t>
+                        <a:t>Naive Bayes, Decision Tree</a:t>
                       </a:r>
                     </a:p>
                   </a:txBody>
@@ -16423,7 +16586,7 @@
                         </a:defRPr>
                       </a:pPr>
                       <a:r>
-                        <a:t>Prioritas alokasi sumber daya</a:t>
+                        <a:t>Kelas risiko Low / Medium / High</a:t>
                       </a:r>
                     </a:p>
                   </a:txBody>
@@ -16447,7 +16610,37 @@
                         </a:defRPr>
                       </a:pPr>
                       <a:r>
-                        <a:t>Tidak prediktif berbasis data</a:t>
+                        <a:t>Kelas diskret; tanpa sumber daya bersama</a:t>
+                      </a:r>
+                    </a:p>
+                  </a:txBody>
+                  <a:tcPr marL="73152" marR="73152" marT="18288" marB="18288" anchor="ctr">
+                    <a:solidFill>
+                      <a:srgbClr val="F4F7F1"/>
+                    </a:solidFill>
+                  </a:tcPr>
+                </a:tc>
+                <a:tc>
+                  <a:txBody>
+                    <a:bodyPr/>
+                    <a:lstStyle/>
+                    <a:p>
+                      <a:pPr algn="ctr">
+                        <a:defRPr sz="950" b="0">
+                          <a:solidFill>
+                            <a:srgbClr val="233324"/>
+                          </a:solidFill>
+                          <a:latin typeface="Calibri"/>
+                        </a:defRPr>
+                      </a:pPr>
+                      <a:r>
+                        <a:rPr u="sng">
+                          <a:solidFill>
+                            <a:srgbClr val="2C5F2D"/>
+                          </a:solidFill>
+                          <a:hlinkClick r:id="rId5"/>
+                        </a:rPr>
+                        <a:t>DOI ↗</a:t>
                       </a:r>
                     </a:p>
                   </a:txBody>
@@ -16473,7 +16666,7 @@
                         </a:defRPr>
                       </a:pPr>
                       <a:r>
-                        <a:t>Kula et al. (2023)</a:t>
+                        <a:t>Browning &amp; Yassine (2010)</a:t>
                       </a:r>
                     </a:p>
                   </a:txBody>
@@ -16497,7 +16690,7 @@
                         </a:defRPr>
                       </a:pPr>
                       <a:r>
-                        <a:t>Model prediksi pengiriman software</a:t>
+                        <a:t>20 priority rule RCMPSP</a:t>
                       </a:r>
                     </a:p>
                   </a:txBody>
@@ -16521,7 +16714,7 @@
                         </a:defRPr>
                       </a:pPr>
                       <a:r>
-                        <a:t>Prediksi delay tingkat epic</a:t>
+                        <a:t>Prioritas alokasi sumber daya</a:t>
                       </a:r>
                     </a:p>
                   </a:txBody>
@@ -16545,7 +16738,37 @@
                         </a:defRPr>
                       </a:pPr>
                       <a:r>
-                        <a:t>Tiap unit diperlakukan independen</a:t>
+                        <a:t>Heuristik statis, tidak prediktif</a:t>
+                      </a:r>
+                    </a:p>
+                  </a:txBody>
+                  <a:tcPr marL="73152" marR="73152" marT="18288" marB="18288" anchor="ctr">
+                    <a:solidFill>
+                      <a:srgbClr val="FFFFFF"/>
+                    </a:solidFill>
+                  </a:tcPr>
+                </a:tc>
+                <a:tc>
+                  <a:txBody>
+                    <a:bodyPr/>
+                    <a:lstStyle/>
+                    <a:p>
+                      <a:pPr algn="ctr">
+                        <a:defRPr sz="950" b="0">
+                          <a:solidFill>
+                            <a:srgbClr val="233324"/>
+                          </a:solidFill>
+                          <a:latin typeface="Calibri"/>
+                        </a:defRPr>
+                      </a:pPr>
+                      <a:r>
+                        <a:rPr u="sng">
+                          <a:solidFill>
+                            <a:srgbClr val="2C5F2D"/>
+                          </a:solidFill>
+                          <a:hlinkClick r:id="rId6"/>
+                        </a:rPr>
+                        <a:t>Cari ↗</a:t>
                       </a:r>
                     </a:p>
                   </a:txBody>
@@ -16653,6 +16876,36 @@
                     </a:solidFill>
                   </a:tcPr>
                 </a:tc>
+                <a:tc>
+                  <a:txBody>
+                    <a:bodyPr/>
+                    <a:lstStyle/>
+                    <a:p>
+                      <a:pPr algn="ctr">
+                        <a:defRPr sz="950" b="0">
+                          <a:solidFill>
+                            <a:srgbClr val="233324"/>
+                          </a:solidFill>
+                          <a:latin typeface="Calibri"/>
+                        </a:defRPr>
+                      </a:pPr>
+                      <a:r>
+                        <a:rPr u="sng">
+                          <a:solidFill>
+                            <a:srgbClr val="2C5F2D"/>
+                          </a:solidFill>
+                          <a:hlinkClick r:id="rId7"/>
+                        </a:rPr>
+                        <a:t>DOI ↗</a:t>
+                      </a:r>
+                    </a:p>
+                  </a:txBody>
+                  <a:tcPr marL="73152" marR="73152" marT="18288" marB="18288" anchor="ctr">
+                    <a:solidFill>
+                      <a:srgbClr val="F4F7F1"/>
+                    </a:solidFill>
+                  </a:tcPr>
+                </a:tc>
               </a:tr>
               <a:tr h="402336">
                 <a:tc>
@@ -16693,7 +16946,7 @@
                         </a:defRPr>
                       </a:pPr>
                       <a:r>
-                        <a:t>Expected Calibration Error</a:t>
+                        <a:t>Temperature Scaling, ECE</a:t>
                       </a:r>
                     </a:p>
                   </a:txBody>
@@ -16741,7 +16994,37 @@
                         </a:defRPr>
                       </a:pPr>
                       <a:r>
-                        <a:t>Bukan konteks manajemen proyek</a:t>
+                        <a:t>Domain computer vision dan NLP</a:t>
+                      </a:r>
+                    </a:p>
+                  </a:txBody>
+                  <a:tcPr marL="73152" marR="73152" marT="18288" marB="18288" anchor="ctr">
+                    <a:solidFill>
+                      <a:srgbClr val="FFFFFF"/>
+                    </a:solidFill>
+                  </a:tcPr>
+                </a:tc>
+                <a:tc>
+                  <a:txBody>
+                    <a:bodyPr/>
+                    <a:lstStyle/>
+                    <a:p>
+                      <a:pPr algn="ctr">
+                        <a:defRPr sz="950" b="0">
+                          <a:solidFill>
+                            <a:srgbClr val="233324"/>
+                          </a:solidFill>
+                          <a:latin typeface="Calibri"/>
+                        </a:defRPr>
+                      </a:pPr>
+                      <a:r>
+                        <a:rPr u="sng">
+                          <a:solidFill>
+                            <a:srgbClr val="2C5F2D"/>
+                          </a:solidFill>
+                          <a:hlinkClick r:id="rId8"/>
+                        </a:rPr>
+                        <a:t>arXiv ↗</a:t>
                       </a:r>
                     </a:p>
                   </a:txBody>
@@ -16767,7 +17050,7 @@
                         </a:defRPr>
                       </a:pPr>
                       <a:r>
-                        <a:t>Mirjalili et al. (2025)</a:t>
+                        <a:t>Cabanillas et al. (2014)</a:t>
                       </a:r>
                     </a:p>
                   </a:txBody>
@@ -16791,7 +17074,7 @@
                         </a:defRPr>
                       </a:pPr>
                       <a:r>
-                        <a:t>Graph Neural Network untuk RCPSP</a:t>
+                        <a:t>Predictive task monitoring</a:t>
                       </a:r>
                     </a:p>
                   </a:txBody>
@@ -16815,7 +17098,7 @@
                         </a:defRPr>
                       </a:pPr>
                       <a:r>
-                        <a:t>Durasi &amp; biaya jaringan proyek</a:t>
+                        <a:t>Probabilitas pelanggaran deadline</a:t>
                       </a:r>
                     </a:p>
                   </a:txBody>
@@ -16839,7 +17122,37 @@
                         </a:defRPr>
                       </a:pPr>
                       <a:r>
-                        <a:t>Luaran regresi, bukan probabilitas delay</a:t>
+                        <a:t>Bergantung log proses sekuensial</a:t>
+                      </a:r>
+                    </a:p>
+                  </a:txBody>
+                  <a:tcPr marL="73152" marR="73152" marT="18288" marB="18288" anchor="ctr">
+                    <a:solidFill>
+                      <a:srgbClr val="F4F7F1"/>
+                    </a:solidFill>
+                  </a:tcPr>
+                </a:tc>
+                <a:tc>
+                  <a:txBody>
+                    <a:bodyPr/>
+                    <a:lstStyle/>
+                    <a:p>
+                      <a:pPr algn="ctr">
+                        <a:defRPr sz="950" b="0">
+                          <a:solidFill>
+                            <a:srgbClr val="233324"/>
+                          </a:solidFill>
+                          <a:latin typeface="Calibri"/>
+                        </a:defRPr>
+                      </a:pPr>
+                      <a:r>
+                        <a:rPr u="sng">
+                          <a:solidFill>
+                            <a:srgbClr val="2C5F2D"/>
+                          </a:solidFill>
+                          <a:hlinkClick r:id="rId9"/>
+                        </a:rPr>
+                        <a:t>Cari ↗</a:t>
                       </a:r>
                     </a:p>
                   </a:txBody>
@@ -16854,6 +17167,210 @@
           </a:graphicData>
         </a:graphic>
       </p:graphicFrame>
+      <p:sp>
+        <p:nvSpPr>
+          <p:cNvPr id="8" name="TextBox 7"/>
+          <p:cNvSpPr txBox="1"/>
+          <p:nvPr/>
+        </p:nvSpPr>
+        <p:spPr>
+          <a:xfrm>
+            <a:off x="731520" y="5760720"/>
+            <a:ext cx="2834640" cy="320040"/>
+          </a:xfrm>
+          <a:prstGeom prst="rect">
+            <a:avLst/>
+          </a:prstGeom>
+          <a:noFill/>
+        </p:spPr>
+        <p:txBody>
+          <a:bodyPr wrap="square" lIns="0" tIns="0" rIns="0" bIns="0">
+            <a:spAutoFit/>
+          </a:bodyPr>
+          <a:lstStyle/>
+          <a:p>
+            <a:pPr algn="l">
+              <a:lnSpc>
+                <a:spcPct val="100000"/>
+              </a:lnSpc>
+              <a:defRPr sz="1050" b="0">
+                <a:solidFill>
+                  <a:srgbClr val="5B6B5C"/>
+                </a:solidFill>
+                <a:latin typeface="Calibri"/>
+              </a:defRPr>
+            </a:pPr>
+            <a:r>
+              <a:t>Dokumen lengkap:</a:t>
+            </a:r>
+          </a:p>
+        </p:txBody>
+      </p:sp>
+      <p:sp>
+        <p:nvSpPr>
+          <p:cNvPr id="9" name="TextBox 8"/>
+          <p:cNvSpPr txBox="1"/>
+          <p:nvPr/>
+        </p:nvSpPr>
+        <p:spPr>
+          <a:xfrm>
+            <a:off x="2331720" y="5760720"/>
+            <a:ext cx="3017520" cy="320040"/>
+          </a:xfrm>
+          <a:prstGeom prst="rect">
+            <a:avLst/>
+          </a:prstGeom>
+          <a:noFill/>
+        </p:spPr>
+        <p:txBody>
+          <a:bodyPr wrap="square" lIns="0" tIns="0" rIns="0" bIns="0">
+            <a:spAutoFit/>
+          </a:bodyPr>
+          <a:lstStyle/>
+          <a:p>
+            <a:pPr algn="l">
+              <a:lnSpc>
+                <a:spcPct val="100000"/>
+              </a:lnSpc>
+              <a:defRPr sz="1050" b="1">
+                <a:solidFill>
+                  <a:srgbClr val="2C5F2D"/>
+                </a:solidFill>
+                <a:latin typeface="Calibri"/>
+              </a:defRPr>
+            </a:pPr>
+            <a:r>
+              <a:rPr u="sng">
+                <a:hlinkClick r:id="rId10"/>
+              </a:rPr>
+              <a:t>Matriks Literatur P2 (8 paper) ↗</a:t>
+            </a:r>
+          </a:p>
+        </p:txBody>
+      </p:sp>
+      <p:sp>
+        <p:nvSpPr>
+          <p:cNvPr id="10" name="TextBox 9"/>
+          <p:cNvSpPr txBox="1"/>
+          <p:nvPr/>
+        </p:nvSpPr>
+        <p:spPr>
+          <a:xfrm>
+            <a:off x="5486400" y="5760720"/>
+            <a:ext cx="2834640" cy="320040"/>
+          </a:xfrm>
+          <a:prstGeom prst="rect">
+            <a:avLst/>
+          </a:prstGeom>
+          <a:noFill/>
+        </p:spPr>
+        <p:txBody>
+          <a:bodyPr wrap="square" lIns="0" tIns="0" rIns="0" bIns="0">
+            <a:spAutoFit/>
+          </a:bodyPr>
+          <a:lstStyle/>
+          <a:p>
+            <a:pPr algn="l">
+              <a:lnSpc>
+                <a:spcPct val="100000"/>
+              </a:lnSpc>
+              <a:defRPr sz="1050" b="1">
+                <a:solidFill>
+                  <a:srgbClr val="2C5F2D"/>
+                </a:solidFill>
+                <a:latin typeface="Calibri"/>
+              </a:defRPr>
+            </a:pPr>
+            <a:r>
+              <a:rPr u="sng">
+                <a:hlinkClick r:id="rId11"/>
+              </a:rPr>
+              <a:t>Tinjauan Pustaka (28 referensi) ↗</a:t>
+            </a:r>
+          </a:p>
+        </p:txBody>
+      </p:sp>
+      <p:sp>
+        <p:nvSpPr>
+          <p:cNvPr id="11" name="TextBox 10"/>
+          <p:cNvSpPr txBox="1"/>
+          <p:nvPr/>
+        </p:nvSpPr>
+        <p:spPr>
+          <a:xfrm>
+            <a:off x="8595360" y="5760720"/>
+            <a:ext cx="2880360" cy="320040"/>
+          </a:xfrm>
+          <a:prstGeom prst="rect">
+            <a:avLst/>
+          </a:prstGeom>
+          <a:noFill/>
+        </p:spPr>
+        <p:txBody>
+          <a:bodyPr wrap="square" lIns="0" tIns="0" rIns="0" bIns="0">
+            <a:spAutoFit/>
+          </a:bodyPr>
+          <a:lstStyle/>
+          <a:p>
+            <a:pPr algn="l">
+              <a:lnSpc>
+                <a:spcPct val="100000"/>
+              </a:lnSpc>
+              <a:defRPr sz="1050" b="1">
+                <a:solidFill>
+                  <a:srgbClr val="2C5F2D"/>
+                </a:solidFill>
+                <a:latin typeface="Calibri"/>
+              </a:defRPr>
+            </a:pPr>
+            <a:r>
+              <a:rPr u="sng">
+                <a:hlinkClick r:id="rId12"/>
+              </a:rPr>
+              <a:t>Research Gap ↗</a:t>
+            </a:r>
+          </a:p>
+        </p:txBody>
+      </p:sp>
+      <p:sp>
+        <p:nvSpPr>
+          <p:cNvPr id="12" name="TextBox 11"/>
+          <p:cNvSpPr txBox="1"/>
+          <p:nvPr/>
+        </p:nvSpPr>
+        <p:spPr>
+          <a:xfrm>
+            <a:off x="731520" y="6144768"/>
+            <a:ext cx="10744200" cy="274320"/>
+          </a:xfrm>
+          <a:prstGeom prst="rect">
+            <a:avLst/>
+          </a:prstGeom>
+          <a:noFill/>
+        </p:spPr>
+        <p:txBody>
+          <a:bodyPr wrap="square" lIns="0" tIns="0" rIns="0" bIns="0">
+            <a:spAutoFit/>
+          </a:bodyPr>
+          <a:lstStyle/>
+          <a:p>
+            <a:pPr algn="l">
+              <a:lnSpc>
+                <a:spcPct val="100000"/>
+              </a:lnSpc>
+              <a:defRPr sz="900" b="0">
+                <a:solidFill>
+                  <a:srgbClr val="5B6B5C"/>
+                </a:solidFill>
+                <a:latin typeface="Calibri"/>
+              </a:defRPr>
+            </a:pPr>
+            <a:r>
+              <a:t>Catatan: DOI Gondia et al. (2020) dan kedua entri bertanda “Cari” belum diverifikasi ke penerbit; gunakan tautan pencarian sebelum dikutip pada naskah akhir.</a:t>
+            </a:r>
+          </a:p>
+        </p:txBody>
+      </p:sp>
     </p:spTree>
   </p:cSld>
   <p:clrMapOvr>

</xml_diff>

<commit_message>
Penjelasan variabel dataset dan sinkronisasi klaim asal data
- Tambah catatan_dosen/Penjelasan_Variabel_Dataset.md: kamus 8 variabel
  (definisi, rumus, sumber dokumen, status penelusuran), 8 contoh
  perhitungan, bagian asumsi, dan tabel isi dataset 26 baris.
- Tambah dataset_pre02_fne_v2.csv (isi identik dengan v1, penomoran versi
  agar sinkron dengan dokumen penjelasan).
- catatan_dosen/analisis_variabel.md ditandai digantikan; dua nama tabel
  yang dikutip tidak ditemukan pada 18 dokumen di MP-datasetRaw/.
- Dokumen P3, slide 8 dan 9, naskah bicara, dan guideline disinkronkan:
  variabel rencana diturunkan dari dokumen, variabel monitoring dan label
  ditetapkan lewat expert judgment; label mengikuti aturan SPI <= 0.90
  yang berlaku untuk 26 dari 26 baris.

Co-Authored-By: Claude Opus 5 <noreply@anthropic.com>
</commit_message>
<xml_diff>
--- a/05_presentasi_progres/PRE02_Presentasi_Progres_Pertemuan1-5.pptx
+++ b/05_presentasi_progres/PRE02_Presentasi_Progres_Pertemuan1-5.pptx
@@ -18680,7 +18680,7 @@
               </a:defRPr>
             </a:pPr>
             <a:r>
-              <a:t>KAK proyek FNE 2026, 8 dokumen PMP, dan 8 dokumen SRS. Sifat data: empiris-simulatif.</a:t>
+              <a:t>KAK proyek FNE 2026, 8 dokumen PMP, dan 8 dokumen SRS — seluruhnya dokumen perencanaan, belum memuat hasil eksekusi.</a:t>
             </a:r>
           </a:p>
         </p:txBody>
@@ -19808,6 +19808,61 @@
             </a:pPr>
             <a:r>
               <a:t>rasio kelas dijaga pada tiap fold cross-validation</a:t>
+            </a:r>
+          </a:p>
+        </p:txBody>
+      </p:sp>
+      <p:sp>
+        <p:nvSpPr>
+          <p:cNvPr id="39" name="TextBox 38"/>
+          <p:cNvSpPr txBox="1"/>
+          <p:nvPr/>
+        </p:nvSpPr>
+        <p:spPr>
+          <a:xfrm>
+            <a:off x="731520" y="6053328"/>
+            <a:ext cx="10744200" cy="411480"/>
+          </a:xfrm>
+          <a:prstGeom prst="rect">
+            <a:avLst/>
+          </a:prstGeom>
+          <a:noFill/>
+        </p:spPr>
+        <p:txBody>
+          <a:bodyPr wrap="square" lIns="0" tIns="0" rIns="0" bIns="0">
+            <a:spAutoFit/>
+          </a:bodyPr>
+          <a:lstStyle/>
+          <a:p>
+            <a:pPr algn="l">
+              <a:lnSpc>
+                <a:spcPct val="125000"/>
+              </a:lnSpc>
+              <a:defRPr sz="900" b="0">
+                <a:solidFill>
+                  <a:srgbClr val="5B6B5C"/>
+                </a:solidFill>
+                <a:latin typeface="Calibri"/>
+              </a:defRPr>
+            </a:pPr>
+            <a:r>
+              <a:t>Asal nilai: durasi, effort, dan dependensi diturunkan dari WBS dan tabel sprint PMP; utilisasi, risk, SPI, dan change request ditetapkan lewat expert judgment</a:t>
+            </a:r>
+          </a:p>
+          <a:p>
+            <a:pPr algn="l">
+              <a:lnSpc>
+                <a:spcPct val="125000"/>
+              </a:lnSpc>
+              <a:defRPr sz="900" b="0">
+                <a:solidFill>
+                  <a:srgbClr val="5B6B5C"/>
+                </a:solidFill>
+                <a:latin typeface="Calibri"/>
+              </a:defRPr>
+            </a:pPr>
+            <a:r>
+              <a:t>mengikuti rumus dan ambang PMP, karena proyek FNE belum memasuki eksekusi — rincian per variabel ada di dokumen Penjelasan Variabel Dataset.</a:t>
             </a:r>
           </a:p>
         </p:txBody>
@@ -21192,8 +21247,8 @@
         </p:nvSpPr>
         <p:spPr>
           <a:xfrm>
-            <a:off x="7589520" y="5029200"/>
-            <a:ext cx="3611880" cy="914400"/>
+            <a:off x="7589520" y="4892040"/>
+            <a:ext cx="3611880" cy="1097280"/>
           </a:xfrm>
           <a:prstGeom prst="rect">
             <a:avLst/>
@@ -21218,7 +21273,7 @@
               </a:defRPr>
             </a:pPr>
             <a:r>
-              <a:t>Catatan kritis: SPI nyaris memisahkan kelas sendirian (terlambat 0.79–0.90; tepat waktu 0.91–0.98). Ini alasan utama metrik pada P5 mendekati sempurna.</a:t>
+              <a:t>Catatan kritis: label ditetapkan mengikuti kondisi SPI ≤ 0.90, sehingga aturan itu berlaku untuk 26 dari 26 baris. Inilah alasan utama metrik pada P5 mendekati sempurna — karena itu eksperimen lanjutan diuji tanpa fitur SPI.</a:t>
             </a:r>
           </a:p>
         </p:txBody>

</xml_diff>

<commit_message>
Jadikan dataset v2 kanonik, verifikasi 3 DOI, dan justifikasi durasi
- Seluruh rujukan berkas data diarahkan ke dataset_pre02_fne_v2.csv;
  versi lama disimpan sebagai dataset_pre02_fne_v1_arsip.csv. Pipeline
  dijalankan ulang memakai v2 dan kedelapan luarannya identik.
- Tiga DOI diverifikasi lewat Crossref dan dimasukkan ke Tinjauan Pustaka:
  Gondia dkk. (2020) 10.1061/(ASCE)CO.1943-7862.0001736; Browning & Yassine
  (2010) 10.1016/j.ijpe.2010.03.009; Cabanillas dkk. (2014)
  10.1007/978-3-319-10172-9_31. Penanda perlu-cek turun dari 24 ke 21.
- Tambah penjelasan mengapa durasi modul tidak berkorespondensi satu-satu
  dengan panjang sprint PMP, beserta catatan peninjauan ACT-001.

Co-Authored-By: Claude Opus 5 <noreply@anthropic.com>
</commit_message>
<xml_diff>
--- a/05_presentasi_progres/PRE02_Presentasi_Progres_Pertemuan1-5.pptx
+++ b/05_presentasi_progres/PRE02_Presentasi_Progres_Pertemuan1-5.pptx
@@ -13330,7 +13330,7 @@
                         </a:defRPr>
                       </a:pPr>
                       <a:r>
-                        <a:t>dataset_pre02_fne.csv (N = 26 × 7 fitur); dokumen P3 lengkap</a:t>
+                        <a:t>dataset_pre02_fne_v2.csv (N = 26 × 7 fitur); dokumen P3 lengkap</a:t>
                       </a:r>
                     </a:p>
                   </a:txBody>
@@ -18441,7 +18441,7 @@
               </a:defRPr>
             </a:pPr>
             <a:r>
-              <a:t>Luaran: dataset siap pakai `dataset_pre02_fne.csv` beserta dokumentasi tahapannya</a:t>
+              <a:t>Luaran: dataset siap pakai `dataset_pre02_fne_v2.csv` beserta dokumentasi tahapannya</a:t>
             </a:r>
           </a:p>
         </p:txBody>

</xml_diff>